<commit_message>
Updated the DR by SNR files
</commit_message>
<xml_diff>
--- a/Presentations/week10presentation.pptx
+++ b/Presentations/week10presentation.pptx
@@ -6869,7 +6869,7 @@
           <p:nvPr>
             <p:extLst>
               <p:ext uri="{D42A27DB-BD31-4B8C-83A1-F6EECF244321}">
-                <p14:modId xmlns:p14="http://schemas.microsoft.com/office/powerpoint/2010/main" val="2529779736"/>
+                <p14:modId xmlns:p14="http://schemas.microsoft.com/office/powerpoint/2010/main" val="3698595719"/>
               </p:ext>
             </p:extLst>
           </p:nvPr>
@@ -6899,7 +6899,7 @@
           <p:nvPr>
             <p:extLst>
               <p:ext uri="{D42A27DB-BD31-4B8C-83A1-F6EECF244321}">
-                <p14:modId xmlns:p14="http://schemas.microsoft.com/office/powerpoint/2010/main" val="3204395236"/>
+                <p14:modId xmlns:p14="http://schemas.microsoft.com/office/powerpoint/2010/main" val="956022901"/>
               </p:ext>
             </p:extLst>
           </p:nvPr>

</xml_diff>